<commit_message>
update pptx for present
</commit_message>
<xml_diff>
--- a/touch-vs-click.pptx
+++ b/touch-vs-click.pptx
@@ -5,19 +5,12 @@
     <p:sldMasterId id="2147483648" r:id="rId1"/>
   </p:sldMasterIdLst>
   <p:sldIdLst>
-    <p:sldId id="256" r:id="rId7"/>
-    <p:sldId id="257" r:id="rId8"/>
-    <p:sldId id="258" r:id="rId9"/>
-    <p:sldId id="259" r:id="rId10"/>
-    <p:sldId id="260" r:id="rId11"/>
-    <p:sldId id="261" r:id="rId12"/>
-    <p:sldId id="262" r:id="rId13"/>
-    <p:sldId id="263" r:id="rId14"/>
-    <p:sldId id="264" r:id="rId15"/>
-    <p:sldId id="265" r:id="rId16"/>
-    <p:sldId id="266" r:id="rId17"/>
+    <p:sldId id="256" r:id="rId2"/>
+    <p:sldId id="260" r:id="rId3"/>
+    <p:sldId id="257" r:id="rId4"/>
+    <p:sldId id="258" r:id="rId5"/>
   </p:sldIdLst>
-  <p:sldSz cx="12191695" cy="6858000" type="screen4x3"/>
+  <p:sldSz cx="12192000" cy="6858000"/>
   <p:notesSz cx="6858000" cy="9144000"/>
   <p:defaultTextStyle>
     <a:defPPr>
@@ -114,6 +107,22 @@
       </a:defRPr>
     </a:lvl9pPr>
   </p:defaultTextStyle>
+  <p:extLst>
+    <p:ext uri="{EFAFB233-063F-42B5-8137-9DF3F51BA10A}">
+      <p15:sldGuideLst xmlns:p15="http://schemas.microsoft.com/office/powerpoint/2012/main">
+        <p15:guide id="1" orient="horz" pos="2160">
+          <p15:clr>
+            <a:srgbClr val="A4A3A4"/>
+          </p15:clr>
+        </p15:guide>
+        <p15:guide id="2" pos="2880">
+          <p15:clr>
+            <a:srgbClr val="A4A3A4"/>
+          </p15:clr>
+        </p15:guide>
+      </p15:sldGuideLst>
+    </p:ext>
+  </p:extLst>
 </p:presentation>
 </file>
 
@@ -155,10 +164,9 @@
           <a:lstStyle/>
           <a:p>
             <a:r>
-              <a:rPr lang="en-US" smtClean="0"/>
+              <a:rPr lang="en-US"/>
               <a:t>Click to edit Master title style</a:t>
             </a:r>
-            <a:endParaRPr lang="en-US"/>
           </a:p>
         </p:txBody>
       </p:sp>
@@ -274,10 +282,9 @@
           </a:lstStyle>
           <a:p>
             <a:r>
-              <a:rPr lang="en-US" smtClean="0"/>
+              <a:rPr lang="en-US"/>
               <a:t>Click to edit Master subtitle style</a:t>
             </a:r>
-            <a:endParaRPr lang="en-US"/>
           </a:p>
         </p:txBody>
       </p:sp>
@@ -298,7 +305,7 @@
           <a:p>
             <a:fld id="{5BCAD085-E8A6-8845-BD4E-CB4CCA059FC4}" type="datetimeFigureOut">
               <a:rPr lang="en-US" smtClean="0"/>
-              <a:t>1/27/13</a:t>
+              <a:t>4/19/2026</a:t>
             </a:fld>
             <a:endParaRPr lang="en-US"/>
           </a:p>
@@ -392,10 +399,9 @@
           <a:lstStyle/>
           <a:p>
             <a:r>
-              <a:rPr lang="en-US" smtClean="0"/>
+              <a:rPr lang="en-US"/>
               <a:t>Click to edit Master title style</a:t>
             </a:r>
-            <a:endParaRPr lang="en-US"/>
           </a:p>
         </p:txBody>
       </p:sp>
@@ -416,38 +422,37 @@
           <a:p>
             <a:pPr lvl="0"/>
             <a:r>
-              <a:rPr lang="en-US" smtClean="0"/>
+              <a:rPr lang="en-US"/>
               <a:t>Click to edit Master text styles</a:t>
             </a:r>
           </a:p>
           <a:p>
             <a:pPr lvl="1"/>
             <a:r>
-              <a:rPr lang="en-US" smtClean="0"/>
+              <a:rPr lang="en-US"/>
               <a:t>Second level</a:t>
             </a:r>
           </a:p>
           <a:p>
             <a:pPr lvl="2"/>
             <a:r>
-              <a:rPr lang="en-US" smtClean="0"/>
+              <a:rPr lang="en-US"/>
               <a:t>Third level</a:t>
             </a:r>
           </a:p>
           <a:p>
             <a:pPr lvl="3"/>
             <a:r>
-              <a:rPr lang="en-US" smtClean="0"/>
+              <a:rPr lang="en-US"/>
               <a:t>Fourth level</a:t>
             </a:r>
           </a:p>
           <a:p>
             <a:pPr lvl="4"/>
             <a:r>
-              <a:rPr lang="en-US" smtClean="0"/>
+              <a:rPr lang="en-US"/>
               <a:t>Fifth level</a:t>
             </a:r>
-            <a:endParaRPr lang="en-US"/>
           </a:p>
         </p:txBody>
       </p:sp>
@@ -468,7 +473,7 @@
           <a:p>
             <a:fld id="{5BCAD085-E8A6-8845-BD4E-CB4CCA059FC4}" type="datetimeFigureOut">
               <a:rPr lang="en-US" smtClean="0"/>
-              <a:t>1/27/13</a:t>
+              <a:t>4/19/2026</a:t>
             </a:fld>
             <a:endParaRPr lang="en-US"/>
           </a:p>
@@ -567,10 +572,9 @@
           <a:lstStyle/>
           <a:p>
             <a:r>
-              <a:rPr lang="en-US" smtClean="0"/>
+              <a:rPr lang="en-US"/>
               <a:t>Click to edit Master title style</a:t>
             </a:r>
-            <a:endParaRPr lang="en-US"/>
           </a:p>
         </p:txBody>
       </p:sp>
@@ -596,38 +600,37 @@
           <a:p>
             <a:pPr lvl="0"/>
             <a:r>
-              <a:rPr lang="en-US" smtClean="0"/>
+              <a:rPr lang="en-US"/>
               <a:t>Click to edit Master text styles</a:t>
             </a:r>
           </a:p>
           <a:p>
             <a:pPr lvl="1"/>
             <a:r>
-              <a:rPr lang="en-US" smtClean="0"/>
+              <a:rPr lang="en-US"/>
               <a:t>Second level</a:t>
             </a:r>
           </a:p>
           <a:p>
             <a:pPr lvl="2"/>
             <a:r>
-              <a:rPr lang="en-US" smtClean="0"/>
+              <a:rPr lang="en-US"/>
               <a:t>Third level</a:t>
             </a:r>
           </a:p>
           <a:p>
             <a:pPr lvl="3"/>
             <a:r>
-              <a:rPr lang="en-US" smtClean="0"/>
+              <a:rPr lang="en-US"/>
               <a:t>Fourth level</a:t>
             </a:r>
           </a:p>
           <a:p>
             <a:pPr lvl="4"/>
             <a:r>
-              <a:rPr lang="en-US" smtClean="0"/>
+              <a:rPr lang="en-US"/>
               <a:t>Fifth level</a:t>
             </a:r>
-            <a:endParaRPr lang="en-US"/>
           </a:p>
         </p:txBody>
       </p:sp>
@@ -648,7 +651,7 @@
           <a:p>
             <a:fld id="{5BCAD085-E8A6-8845-BD4E-CB4CCA059FC4}" type="datetimeFigureOut">
               <a:rPr lang="en-US" smtClean="0"/>
-              <a:t>1/27/13</a:t>
+              <a:t>4/19/2026</a:t>
             </a:fld>
             <a:endParaRPr lang="en-US"/>
           </a:p>
@@ -742,10 +745,9 @@
           <a:lstStyle/>
           <a:p>
             <a:r>
-              <a:rPr lang="en-US" smtClean="0"/>
+              <a:rPr lang="en-US"/>
               <a:t>Click to edit Master title style</a:t>
             </a:r>
-            <a:endParaRPr lang="en-US"/>
           </a:p>
         </p:txBody>
       </p:sp>
@@ -766,38 +768,37 @@
           <a:p>
             <a:pPr lvl="0"/>
             <a:r>
-              <a:rPr lang="en-US" smtClean="0"/>
+              <a:rPr lang="en-US"/>
               <a:t>Click to edit Master text styles</a:t>
             </a:r>
           </a:p>
           <a:p>
             <a:pPr lvl="1"/>
             <a:r>
-              <a:rPr lang="en-US" smtClean="0"/>
+              <a:rPr lang="en-US"/>
               <a:t>Second level</a:t>
             </a:r>
           </a:p>
           <a:p>
             <a:pPr lvl="2"/>
             <a:r>
-              <a:rPr lang="en-US" smtClean="0"/>
+              <a:rPr lang="en-US"/>
               <a:t>Third level</a:t>
             </a:r>
           </a:p>
           <a:p>
             <a:pPr lvl="3"/>
             <a:r>
-              <a:rPr lang="en-US" smtClean="0"/>
+              <a:rPr lang="en-US"/>
               <a:t>Fourth level</a:t>
             </a:r>
           </a:p>
           <a:p>
             <a:pPr lvl="4"/>
             <a:r>
-              <a:rPr lang="en-US" smtClean="0"/>
+              <a:rPr lang="en-US"/>
               <a:t>Fifth level</a:t>
             </a:r>
-            <a:endParaRPr lang="en-US"/>
           </a:p>
         </p:txBody>
       </p:sp>
@@ -818,7 +819,7 @@
           <a:p>
             <a:fld id="{5BCAD085-E8A6-8845-BD4E-CB4CCA059FC4}" type="datetimeFigureOut">
               <a:rPr lang="en-US" smtClean="0"/>
-              <a:t>1/27/13</a:t>
+              <a:t>4/19/2026</a:t>
             </a:fld>
             <a:endParaRPr lang="en-US"/>
           </a:p>
@@ -921,10 +922,9 @@
           </a:lstStyle>
           <a:p>
             <a:r>
-              <a:rPr lang="en-US" smtClean="0"/>
+              <a:rPr lang="en-US"/>
               <a:t>Click to edit Master title style</a:t>
             </a:r>
-            <a:endParaRPr lang="en-US"/>
           </a:p>
         </p:txBody>
       </p:sp>
@@ -1041,7 +1041,7 @@
           <a:p>
             <a:pPr lvl="0"/>
             <a:r>
-              <a:rPr lang="en-US" smtClean="0"/>
+              <a:rPr lang="en-US"/>
               <a:t>Click to edit Master text styles</a:t>
             </a:r>
           </a:p>
@@ -1064,7 +1064,7 @@
           <a:p>
             <a:fld id="{5BCAD085-E8A6-8845-BD4E-CB4CCA059FC4}" type="datetimeFigureOut">
               <a:rPr lang="en-US" smtClean="0"/>
-              <a:t>1/27/13</a:t>
+              <a:t>4/19/2026</a:t>
             </a:fld>
             <a:endParaRPr lang="en-US"/>
           </a:p>
@@ -1158,10 +1158,9 @@
           <a:lstStyle/>
           <a:p>
             <a:r>
-              <a:rPr lang="en-US" smtClean="0"/>
+              <a:rPr lang="en-US"/>
               <a:t>Click to edit Master title style</a:t>
             </a:r>
-            <a:endParaRPr lang="en-US"/>
           </a:p>
         </p:txBody>
       </p:sp>
@@ -1215,38 +1214,37 @@
           <a:p>
             <a:pPr lvl="0"/>
             <a:r>
-              <a:rPr lang="en-US" smtClean="0"/>
+              <a:rPr lang="en-US"/>
               <a:t>Click to edit Master text styles</a:t>
             </a:r>
           </a:p>
           <a:p>
             <a:pPr lvl="1"/>
             <a:r>
-              <a:rPr lang="en-US" smtClean="0"/>
+              <a:rPr lang="en-US"/>
               <a:t>Second level</a:t>
             </a:r>
           </a:p>
           <a:p>
             <a:pPr lvl="2"/>
             <a:r>
-              <a:rPr lang="en-US" smtClean="0"/>
+              <a:rPr lang="en-US"/>
               <a:t>Third level</a:t>
             </a:r>
           </a:p>
           <a:p>
             <a:pPr lvl="3"/>
             <a:r>
-              <a:rPr lang="en-US" smtClean="0"/>
+              <a:rPr lang="en-US"/>
               <a:t>Fourth level</a:t>
             </a:r>
           </a:p>
           <a:p>
             <a:pPr lvl="4"/>
             <a:r>
-              <a:rPr lang="en-US" smtClean="0"/>
+              <a:rPr lang="en-US"/>
               <a:t>Fifth level</a:t>
             </a:r>
-            <a:endParaRPr lang="en-US"/>
           </a:p>
         </p:txBody>
       </p:sp>
@@ -1300,38 +1298,37 @@
           <a:p>
             <a:pPr lvl="0"/>
             <a:r>
-              <a:rPr lang="en-US" smtClean="0"/>
+              <a:rPr lang="en-US"/>
               <a:t>Click to edit Master text styles</a:t>
             </a:r>
           </a:p>
           <a:p>
             <a:pPr lvl="1"/>
             <a:r>
-              <a:rPr lang="en-US" smtClean="0"/>
+              <a:rPr lang="en-US"/>
               <a:t>Second level</a:t>
             </a:r>
           </a:p>
           <a:p>
             <a:pPr lvl="2"/>
             <a:r>
-              <a:rPr lang="en-US" smtClean="0"/>
+              <a:rPr lang="en-US"/>
               <a:t>Third level</a:t>
             </a:r>
           </a:p>
           <a:p>
             <a:pPr lvl="3"/>
             <a:r>
-              <a:rPr lang="en-US" smtClean="0"/>
+              <a:rPr lang="en-US"/>
               <a:t>Fourth level</a:t>
             </a:r>
           </a:p>
           <a:p>
             <a:pPr lvl="4"/>
             <a:r>
-              <a:rPr lang="en-US" smtClean="0"/>
+              <a:rPr lang="en-US"/>
               <a:t>Fifth level</a:t>
             </a:r>
-            <a:endParaRPr lang="en-US"/>
           </a:p>
         </p:txBody>
       </p:sp>
@@ -1352,7 +1349,7 @@
           <a:p>
             <a:fld id="{5BCAD085-E8A6-8845-BD4E-CB4CCA059FC4}" type="datetimeFigureOut">
               <a:rPr lang="en-US" smtClean="0"/>
-              <a:t>1/27/13</a:t>
+              <a:t>4/19/2026</a:t>
             </a:fld>
             <a:endParaRPr lang="en-US"/>
           </a:p>
@@ -1450,10 +1447,9 @@
           </a:lstStyle>
           <a:p>
             <a:r>
-              <a:rPr lang="en-US" smtClean="0"/>
+              <a:rPr lang="en-US"/>
               <a:t>Click to edit Master title style</a:t>
             </a:r>
-            <a:endParaRPr lang="en-US"/>
           </a:p>
         </p:txBody>
       </p:sp>
@@ -1516,7 +1512,7 @@
           <a:p>
             <a:pPr lvl="0"/>
             <a:r>
-              <a:rPr lang="en-US" smtClean="0"/>
+              <a:rPr lang="en-US"/>
               <a:t>Click to edit Master text styles</a:t>
             </a:r>
           </a:p>
@@ -1572,38 +1568,37 @@
           <a:p>
             <a:pPr lvl="0"/>
             <a:r>
-              <a:rPr lang="en-US" smtClean="0"/>
+              <a:rPr lang="en-US"/>
               <a:t>Click to edit Master text styles</a:t>
             </a:r>
           </a:p>
           <a:p>
             <a:pPr lvl="1"/>
             <a:r>
-              <a:rPr lang="en-US" smtClean="0"/>
+              <a:rPr lang="en-US"/>
               <a:t>Second level</a:t>
             </a:r>
           </a:p>
           <a:p>
             <a:pPr lvl="2"/>
             <a:r>
-              <a:rPr lang="en-US" smtClean="0"/>
+              <a:rPr lang="en-US"/>
               <a:t>Third level</a:t>
             </a:r>
           </a:p>
           <a:p>
             <a:pPr lvl="3"/>
             <a:r>
-              <a:rPr lang="en-US" smtClean="0"/>
+              <a:rPr lang="en-US"/>
               <a:t>Fourth level</a:t>
             </a:r>
           </a:p>
           <a:p>
             <a:pPr lvl="4"/>
             <a:r>
-              <a:rPr lang="en-US" smtClean="0"/>
+              <a:rPr lang="en-US"/>
               <a:t>Fifth level</a:t>
             </a:r>
-            <a:endParaRPr lang="en-US"/>
           </a:p>
         </p:txBody>
       </p:sp>
@@ -1666,7 +1661,7 @@
           <a:p>
             <a:pPr lvl="0"/>
             <a:r>
-              <a:rPr lang="en-US" smtClean="0"/>
+              <a:rPr lang="en-US"/>
               <a:t>Click to edit Master text styles</a:t>
             </a:r>
           </a:p>
@@ -1722,38 +1717,37 @@
           <a:p>
             <a:pPr lvl="0"/>
             <a:r>
-              <a:rPr lang="en-US" smtClean="0"/>
+              <a:rPr lang="en-US"/>
               <a:t>Click to edit Master text styles</a:t>
             </a:r>
           </a:p>
           <a:p>
             <a:pPr lvl="1"/>
             <a:r>
-              <a:rPr lang="en-US" smtClean="0"/>
+              <a:rPr lang="en-US"/>
               <a:t>Second level</a:t>
             </a:r>
           </a:p>
           <a:p>
             <a:pPr lvl="2"/>
             <a:r>
-              <a:rPr lang="en-US" smtClean="0"/>
+              <a:rPr lang="en-US"/>
               <a:t>Third level</a:t>
             </a:r>
           </a:p>
           <a:p>
             <a:pPr lvl="3"/>
             <a:r>
-              <a:rPr lang="en-US" smtClean="0"/>
+              <a:rPr lang="en-US"/>
               <a:t>Fourth level</a:t>
             </a:r>
           </a:p>
           <a:p>
             <a:pPr lvl="4"/>
             <a:r>
-              <a:rPr lang="en-US" smtClean="0"/>
+              <a:rPr lang="en-US"/>
               <a:t>Fifth level</a:t>
             </a:r>
-            <a:endParaRPr lang="en-US"/>
           </a:p>
         </p:txBody>
       </p:sp>
@@ -1774,7 +1768,7 @@
           <a:p>
             <a:fld id="{5BCAD085-E8A6-8845-BD4E-CB4CCA059FC4}" type="datetimeFigureOut">
               <a:rPr lang="en-US" smtClean="0"/>
-              <a:t>1/27/13</a:t>
+              <a:t>4/19/2026</a:t>
             </a:fld>
             <a:endParaRPr lang="en-US"/>
           </a:p>
@@ -1868,10 +1862,9 @@
           <a:lstStyle/>
           <a:p>
             <a:r>
-              <a:rPr lang="en-US" smtClean="0"/>
+              <a:rPr lang="en-US"/>
               <a:t>Click to edit Master title style</a:t>
             </a:r>
-            <a:endParaRPr lang="en-US"/>
           </a:p>
         </p:txBody>
       </p:sp>
@@ -1892,7 +1885,7 @@
           <a:p>
             <a:fld id="{5BCAD085-E8A6-8845-BD4E-CB4CCA059FC4}" type="datetimeFigureOut">
               <a:rPr lang="en-US" smtClean="0"/>
-              <a:t>1/27/13</a:t>
+              <a:t>4/19/2026</a:t>
             </a:fld>
             <a:endParaRPr lang="en-US"/>
           </a:p>
@@ -1987,7 +1980,7 @@
           <a:p>
             <a:fld id="{5BCAD085-E8A6-8845-BD4E-CB4CCA059FC4}" type="datetimeFigureOut">
               <a:rPr lang="en-US" smtClean="0"/>
-              <a:t>1/27/13</a:t>
+              <a:t>4/19/2026</a:t>
             </a:fld>
             <a:endParaRPr lang="en-US"/>
           </a:p>
@@ -2090,10 +2083,9 @@
           </a:lstStyle>
           <a:p>
             <a:r>
-              <a:rPr lang="en-US" smtClean="0"/>
+              <a:rPr lang="en-US"/>
               <a:t>Click to edit Master title style</a:t>
             </a:r>
-            <a:endParaRPr lang="en-US"/>
           </a:p>
         </p:txBody>
       </p:sp>
@@ -2147,38 +2139,37 @@
           <a:p>
             <a:pPr lvl="0"/>
             <a:r>
-              <a:rPr lang="en-US" smtClean="0"/>
+              <a:rPr lang="en-US"/>
               <a:t>Click to edit Master text styles</a:t>
             </a:r>
           </a:p>
           <a:p>
             <a:pPr lvl="1"/>
             <a:r>
-              <a:rPr lang="en-US" smtClean="0"/>
+              <a:rPr lang="en-US"/>
               <a:t>Second level</a:t>
             </a:r>
           </a:p>
           <a:p>
             <a:pPr lvl="2"/>
             <a:r>
-              <a:rPr lang="en-US" smtClean="0"/>
+              <a:rPr lang="en-US"/>
               <a:t>Third level</a:t>
             </a:r>
           </a:p>
           <a:p>
             <a:pPr lvl="3"/>
             <a:r>
-              <a:rPr lang="en-US" smtClean="0"/>
+              <a:rPr lang="en-US"/>
               <a:t>Fourth level</a:t>
             </a:r>
           </a:p>
           <a:p>
             <a:pPr lvl="4"/>
             <a:r>
-              <a:rPr lang="en-US" smtClean="0"/>
+              <a:rPr lang="en-US"/>
               <a:t>Fifth level</a:t>
             </a:r>
-            <a:endParaRPr lang="en-US"/>
           </a:p>
         </p:txBody>
       </p:sp>
@@ -2241,7 +2232,7 @@
           <a:p>
             <a:pPr lvl="0"/>
             <a:r>
-              <a:rPr lang="en-US" smtClean="0"/>
+              <a:rPr lang="en-US"/>
               <a:t>Click to edit Master text styles</a:t>
             </a:r>
           </a:p>
@@ -2264,7 +2255,7 @@
           <a:p>
             <a:fld id="{5BCAD085-E8A6-8845-BD4E-CB4CCA059FC4}" type="datetimeFigureOut">
               <a:rPr lang="en-US" smtClean="0"/>
-              <a:t>1/27/13</a:t>
+              <a:t>4/19/2026</a:t>
             </a:fld>
             <a:endParaRPr lang="en-US"/>
           </a:p>
@@ -2367,10 +2358,9 @@
           </a:lstStyle>
           <a:p>
             <a:r>
-              <a:rPr lang="en-US" smtClean="0"/>
+              <a:rPr lang="en-US"/>
               <a:t>Click to edit Master title style</a:t>
             </a:r>
-            <a:endParaRPr lang="en-US"/>
           </a:p>
         </p:txBody>
       </p:sp>
@@ -2494,7 +2484,7 @@
           <a:p>
             <a:pPr lvl="0"/>
             <a:r>
-              <a:rPr lang="en-US" smtClean="0"/>
+              <a:rPr lang="en-US"/>
               <a:t>Click to edit Master text styles</a:t>
             </a:r>
           </a:p>
@@ -2517,7 +2507,7 @@
           <a:p>
             <a:fld id="{5BCAD085-E8A6-8845-BD4E-CB4CCA059FC4}" type="datetimeFigureOut">
               <a:rPr lang="en-US" smtClean="0"/>
-              <a:t>1/27/13</a:t>
+              <a:t>4/19/2026</a:t>
             </a:fld>
             <a:endParaRPr lang="en-US"/>
           </a:p>
@@ -2626,10 +2616,9 @@
           <a:lstStyle/>
           <a:p>
             <a:r>
-              <a:rPr lang="en-US" smtClean="0"/>
+              <a:rPr lang="en-US"/>
               <a:t>Click to edit Master title style</a:t>
             </a:r>
-            <a:endParaRPr lang="en-US"/>
           </a:p>
         </p:txBody>
       </p:sp>
@@ -2660,38 +2649,37 @@
           <a:p>
             <a:pPr lvl="0"/>
             <a:r>
-              <a:rPr lang="en-US" smtClean="0"/>
+              <a:rPr lang="en-US"/>
               <a:t>Click to edit Master text styles</a:t>
             </a:r>
           </a:p>
           <a:p>
             <a:pPr lvl="1"/>
             <a:r>
-              <a:rPr lang="en-US" smtClean="0"/>
+              <a:rPr lang="en-US"/>
               <a:t>Second level</a:t>
             </a:r>
           </a:p>
           <a:p>
             <a:pPr lvl="2"/>
             <a:r>
-              <a:rPr lang="en-US" smtClean="0"/>
+              <a:rPr lang="en-US"/>
               <a:t>Third level</a:t>
             </a:r>
           </a:p>
           <a:p>
             <a:pPr lvl="3"/>
             <a:r>
-              <a:rPr lang="en-US" smtClean="0"/>
+              <a:rPr lang="en-US"/>
               <a:t>Fourth level</a:t>
             </a:r>
           </a:p>
           <a:p>
             <a:pPr lvl="4"/>
             <a:r>
-              <a:rPr lang="en-US" smtClean="0"/>
+              <a:rPr lang="en-US"/>
               <a:t>Fifth level</a:t>
             </a:r>
-            <a:endParaRPr lang="en-US"/>
           </a:p>
         </p:txBody>
       </p:sp>
@@ -2730,7 +2718,7 @@
           <a:p>
             <a:fld id="{5BCAD085-E8A6-8845-BD4E-CB4CCA059FC4}" type="datetimeFigureOut">
               <a:rPr lang="en-US" smtClean="0"/>
-              <a:t>1/27/13</a:t>
+              <a:t>4/19/2026</a:t>
             </a:fld>
             <a:endParaRPr lang="en-US"/>
           </a:p>
@@ -3089,7 +3077,7 @@
 </file>
 
 <file path=ppt/slides/slide1.xml><?xml version="1.0" encoding="utf-8"?>
-<p:sld xmlns:a="http://schemas.openxmlformats.org/drawingml/2006/main" xmlns:p="http://schemas.openxmlformats.org/presentationml/2006/main" xmlns:r="http://schemas.openxmlformats.org/officeDocument/2006/relationships">
+<p:sld xmlns:a="http://schemas.openxmlformats.org/drawingml/2006/main" xmlns:r="http://schemas.openxmlformats.org/officeDocument/2006/relationships" xmlns:p="http://schemas.openxmlformats.org/presentationml/2006/main">
   <p:cSld>
     <p:spTree>
       <p:nvGrpSpPr>
@@ -3097,7 +3085,14 @@
         <p:cNvGrpSpPr/>
         <p:nvPr/>
       </p:nvGrpSpPr>
-      <p:grpSpPr/>
+      <p:grpSpPr>
+        <a:xfrm>
+          <a:off x="0" y="0"/>
+          <a:ext cx="0" cy="0"/>
+          <a:chOff x="0" y="0"/>
+          <a:chExt cx="0" cy="0"/>
+        </a:xfrm>
+      </p:grpSpPr>
       <p:sp>
         <p:nvSpPr>
           <p:cNvPr id="2" name="Title 1"/>
@@ -3105,66 +3100,6 @@
             <a:spLocks noGrp="1"/>
           </p:cNvSpPr>
           <p:nvPr>
-            <p:ph type="ctrTitle"/>
-          </p:nvPr>
-        </p:nvSpPr>
-        <p:spPr/>
-        <p:txBody>
-          <a:bodyPr/>
-          <a:lstStyle/>
-          <a:p>
-            <a:r>
-              <a:t>Touch vs Click</a:t>
-            </a:r>
-          </a:p>
-        </p:txBody>
-      </p:sp>
-      <p:sp>
-        <p:nvSpPr>
-          <p:cNvPr id="3" name="Subtitle 2"/>
-          <p:cNvSpPr>
-            <a:spLocks noGrp="1"/>
-          </p:cNvSpPr>
-          <p:nvPr>
-            <p:ph type="subTitle" idx="1"/>
-          </p:nvPr>
-        </p:nvSpPr>
-        <p:spPr/>
-        <p:txBody>
-          <a:bodyPr/>
-          <a:lstStyle/>
-          <a:p>
-            <a:r>
-              <a:t>Short deck • Diagrams + live demo: demo/index.html</a:t>
-            </a:r>
-          </a:p>
-        </p:txBody>
-      </p:sp>
-    </p:spTree>
-  </p:cSld>
-  <p:clrMapOvr>
-    <a:masterClrMapping/>
-  </p:clrMapOvr>
-</p:sld>
-</file>
-
-<file path=ppt/slides/slide10.xml><?xml version="1.0" encoding="utf-8"?>
-<p:sld xmlns:a="http://schemas.openxmlformats.org/drawingml/2006/main" xmlns:p="http://schemas.openxmlformats.org/presentationml/2006/main" xmlns:r="http://schemas.openxmlformats.org/officeDocument/2006/relationships">
-  <p:cSld>
-    <p:spTree>
-      <p:nvGrpSpPr>
-        <p:cNvPr id="1" name=""/>
-        <p:cNvGrpSpPr/>
-        <p:nvPr/>
-      </p:nvGrpSpPr>
-      <p:grpSpPr/>
-      <p:sp>
-        <p:nvSpPr>
-          <p:cNvPr id="2" name="Title 1"/>
-          <p:cNvSpPr>
-            <a:spLocks noGrp="1"/>
-          </p:cNvSpPr>
-          <p:nvPr>
             <p:ph type="title"/>
           </p:nvPr>
         </p:nvSpPr>
@@ -3174,129 +3109,10 @@
           <a:lstStyle/>
           <a:p>
             <a:r>
-              <a:t>Real apps — use touch (or Pointer Events)</a:t>
-            </a:r>
-          </a:p>
-        </p:txBody>
-      </p:sp>
-      <p:sp>
-        <p:nvSpPr>
-          <p:cNvPr id="3" name="Content Placeholder 2"/>
-          <p:cNvSpPr>
-            <a:spLocks noGrp="1"/>
-          </p:cNvSpPr>
-          <p:nvPr>
-            <p:ph idx="1"/>
-          </p:nvPr>
-        </p:nvSpPr>
-        <p:spPr/>
-        <p:txBody>
-          <a:bodyPr/>
-          <a:lstStyle/>
-          <a:p>
-            <a:pPr>
-              <a:defRPr sz="2200">
-                <a:latin typeface="Calibri"/>
-              </a:defRPr>
-            </a:pPr>
-            <a:r>
-              <a:t>Slider thumb, map drag, sortable row drag, signature pad, game control.</a:t>
-            </a:r>
-          </a:p>
-          <a:p>
-            <a:pPr>
-              <a:defRPr sz="2200">
-                <a:latin typeface="Calibri"/>
-              </a:defRPr>
-            </a:pPr>
-            <a:r>
-              <a:t>Custom gestures (swipe distance, long-press) where you read many move points.</a:t>
-            </a:r>
-          </a:p>
-          <a:p>
-            <a:pPr>
-              <a:defRPr sz="2200">
-                <a:latin typeface="Calibri"/>
-              </a:defRPr>
-            </a:pPr>
-            <a:r>
-              <a:t>New code: Pointer Events often replace separate mouse + touch handlers for drags.</a:t>
-            </a:r>
-          </a:p>
-        </p:txBody>
-      </p:sp>
-    </p:spTree>
-  </p:cSld>
-  <p:clrMapOvr>
-    <a:masterClrMapping/>
-  </p:clrMapOvr>
-</p:sld>
-</file>
-
-<file path=ppt/slides/slide11.xml><?xml version="1.0" encoding="utf-8"?>
-<p:sld xmlns:a="http://schemas.openxmlformats.org/drawingml/2006/main" xmlns:p="http://schemas.openxmlformats.org/presentationml/2006/main" xmlns:r="http://schemas.openxmlformats.org/officeDocument/2006/relationships">
-  <p:cSld>
-    <p:spTree>
-      <p:nvGrpSpPr>
-        <p:cNvPr id="1" name=""/>
-        <p:cNvGrpSpPr/>
-        <p:nvPr/>
-      </p:nvGrpSpPr>
-      <p:grpSpPr/>
-      <p:sp>
-        <p:nvSpPr>
-          <p:cNvPr id="2" name="Title 1"/>
-          <p:cNvSpPr>
-            <a:spLocks noGrp="1"/>
-          </p:cNvSpPr>
-          <p:nvPr>
-            <p:ph type="title"/>
-          </p:nvPr>
-        </p:nvSpPr>
-        <p:spPr/>
-        <p:txBody>
-          <a:bodyPr/>
-          <a:lstStyle/>
-          <a:p>
-            <a:r>
-              <a:t>Demo</a:t>
-            </a:r>
-          </a:p>
-        </p:txBody>
-      </p:sp>
-      <p:sp>
-        <p:nvSpPr>
-          <p:cNvPr id="3" name="Content Placeholder 2"/>
-          <p:cNvSpPr>
-            <a:spLocks noGrp="1"/>
-          </p:cNvSpPr>
-          <p:nvPr>
-            <p:ph idx="1"/>
-          </p:nvPr>
-        </p:nvSpPr>
-        <p:spPr/>
-        <p:txBody>
-          <a:bodyPr/>
-          <a:lstStyle/>
-          <a:p>
-            <a:pPr>
-              <a:defRPr sz="2200">
-                <a:latin typeface="Calibri"/>
-              </a:defRPr>
-            </a:pPr>
-            <a:r>
-              <a:t>Open demo/index.html (+ demo.js, demo.css). [1 tap] = button; [2 drag] = same TAP_EVENT_TYPES on one draggable thumb — compare quick tap vs drag.</a:t>
-            </a:r>
-          </a:p>
-          <a:p>
-            <a:pPr>
-              <a:defRPr sz="2200">
-                <a:latin typeface="Calibri"/>
-              </a:defRPr>
-            </a:pPr>
-            <a:r>
-              <a:t>pointermove / touchmove are not in TAP_EVENT_TYPES and are not logged separately.</a:t>
-            </a:r>
+              <a:rPr lang="en-US"/>
+              <a:t>Click and touch event</a:t>
+            </a:r>
+            <a:endParaRPr/>
           </a:p>
         </p:txBody>
       </p:sp>
@@ -3309,18 +3125,37 @@
 </file>
 
 <file path=ppt/slides/slide2.xml><?xml version="1.0" encoding="utf-8"?>
-<p:sld xmlns:a="http://schemas.openxmlformats.org/drawingml/2006/main" xmlns:p="http://schemas.openxmlformats.org/presentationml/2006/main" xmlns:r="http://schemas.openxmlformats.org/officeDocument/2006/relationships">
+<p:sld xmlns:a="http://schemas.openxmlformats.org/drawingml/2006/main" xmlns:r="http://schemas.openxmlformats.org/officeDocument/2006/relationships" xmlns:p="http://schemas.openxmlformats.org/presentationml/2006/main">
   <p:cSld>
     <p:spTree>
       <p:nvGrpSpPr>
-        <p:cNvPr id="1" name=""/>
+        <p:cNvPr id="1" name="">
+          <a:extLst>
+            <a:ext uri="{FF2B5EF4-FFF2-40B4-BE49-F238E27FC236}">
+              <a16:creationId xmlns:a16="http://schemas.microsoft.com/office/drawing/2014/main" id="{8253A68A-A798-3AD3-531B-48BCE2775DE2}"/>
+            </a:ext>
+          </a:extLst>
+        </p:cNvPr>
         <p:cNvGrpSpPr/>
         <p:nvPr/>
       </p:nvGrpSpPr>
-      <p:grpSpPr/>
-      <p:sp>
-        <p:nvSpPr>
-          <p:cNvPr id="2" name="Title 1"/>
+      <p:grpSpPr>
+        <a:xfrm>
+          <a:off x="0" y="0"/>
+          <a:ext cx="0" cy="0"/>
+          <a:chOff x="0" y="0"/>
+          <a:chExt cx="0" cy="0"/>
+        </a:xfrm>
+      </p:grpSpPr>
+      <p:sp>
+        <p:nvSpPr>
+          <p:cNvPr id="2" name="Title 1">
+            <a:extLst>
+              <a:ext uri="{FF2B5EF4-FFF2-40B4-BE49-F238E27FC236}">
+                <a16:creationId xmlns:a16="http://schemas.microsoft.com/office/drawing/2014/main" id="{AA7449AE-D5C0-BA27-134F-F52D116D0603}"/>
+              </a:ext>
+            </a:extLst>
+          </p:cNvPr>
           <p:cNvSpPr>
             <a:spLocks noGrp="1"/>
           </p:cNvSpPr>
@@ -3334,14 +3169,20 @@
           <a:lstStyle/>
           <a:p>
             <a:r>
-              <a:t>Click</a:t>
-            </a:r>
-          </a:p>
-        </p:txBody>
-      </p:sp>
-      <p:sp>
-        <p:nvSpPr>
-          <p:cNvPr id="3" name="Content Placeholder 2"/>
+              <a:t>1 — click</a:t>
+            </a:r>
+          </a:p>
+        </p:txBody>
+      </p:sp>
+      <p:sp>
+        <p:nvSpPr>
+          <p:cNvPr id="3" name="Content Placeholder 2">
+            <a:extLst>
+              <a:ext uri="{FF2B5EF4-FFF2-40B4-BE49-F238E27FC236}">
+                <a16:creationId xmlns:a16="http://schemas.microsoft.com/office/drawing/2014/main" id="{2E33CE20-3B8B-BD1D-D7DE-82798B241A1B}"/>
+              </a:ext>
+            </a:extLst>
+          </p:cNvPr>
           <p:cNvSpPr>
             <a:spLocks noGrp="1"/>
           </p:cNvSpPr>
@@ -3355,37 +3196,52 @@
           <a:lstStyle/>
           <a:p>
             <a:pPr>
-              <a:defRPr sz="2200">
+              <a:defRPr sz="2100">
                 <a:latin typeface="Calibri"/>
               </a:defRPr>
             </a:pPr>
             <a:r>
-              <a:t>One DOM event: click.</a:t>
+              <a:t>element.addEventListener("click", fn) — one activation event type.</a:t>
             </a:r>
           </a:p>
           <a:p>
             <a:pPr>
-              <a:defRPr sz="2200">
+              <a:defRPr sz="2100">
                 <a:latin typeface="Calibri"/>
               </a:defRPr>
             </a:pPr>
             <a:r>
-              <a:t>Fires when the browser treats a press-and-release as “activate this” (mouse, and often after a tap on phones).</a:t>
+              <a:t>Often after mousedown + mouseup; tap on glass can still fire click (+ compat mouse*).</a:t>
             </a:r>
           </a:p>
           <a:p>
             <a:pPr>
-              <a:defRPr sz="2200">
+              <a:defRPr sz="2100">
                 <a:latin typeface="Calibri"/>
               </a:defRPr>
             </a:pPr>
             <a:r>
-              <a:t>Good when you only need that single moment — like pressing a doorbell once.</a:t>
+              <a:t>e.g. primary &lt;button&gt;, &lt;a href&gt;, modal OK / Cancel — usually click.</a:t>
+            </a:r>
+          </a:p>
+          <a:p>
+            <a:pPr>
+              <a:defRPr sz="2100">
+                <a:latin typeface="Calibri"/>
+              </a:defRPr>
+            </a:pPr>
+            <a:r>
+              <a:t>demo/index.html — click line shows pointerType (metadata).</a:t>
             </a:r>
           </a:p>
         </p:txBody>
       </p:sp>
     </p:spTree>
+    <p:extLst>
+      <p:ext uri="{BB962C8B-B14F-4D97-AF65-F5344CB8AC3E}">
+        <p14:creationId xmlns:p14="http://schemas.microsoft.com/office/powerpoint/2010/main" val="585434463"/>
+      </p:ext>
+    </p:extLst>
   </p:cSld>
   <p:clrMapOvr>
     <a:masterClrMapping/>
@@ -3394,7 +3250,7 @@
 </file>
 
 <file path=ppt/slides/slide3.xml><?xml version="1.0" encoding="utf-8"?>
-<p:sld xmlns:a="http://schemas.openxmlformats.org/drawingml/2006/main" xmlns:p="http://schemas.openxmlformats.org/presentationml/2006/main" xmlns:r="http://schemas.openxmlformats.org/officeDocument/2006/relationships">
+<p:sld xmlns:a="http://schemas.openxmlformats.org/drawingml/2006/main" xmlns:r="http://schemas.openxmlformats.org/officeDocument/2006/relationships" xmlns:p="http://schemas.openxmlformats.org/presentationml/2006/main">
   <p:cSld>
     <p:spTree>
       <p:nvGrpSpPr>
@@ -3402,7 +3258,14 @@
         <p:cNvGrpSpPr/>
         <p:nvPr/>
       </p:nvGrpSpPr>
-      <p:grpSpPr/>
+      <p:grpSpPr>
+        <a:xfrm>
+          <a:off x="0" y="0"/>
+          <a:ext cx="0" cy="0"/>
+          <a:chOff x="0" y="0"/>
+          <a:chExt cx="0" cy="0"/>
+        </a:xfrm>
+      </p:grpSpPr>
       <p:sp>
         <p:nvSpPr>
           <p:cNvPr id="2" name="Title 1"/>
@@ -3419,64 +3282,63 @@
           <a:lstStyle/>
           <a:p>
             <a:r>
-              <a:t>Figure — what “click” means</a:t>
-            </a:r>
-          </a:p>
-        </p:txBody>
-      </p:sp>
-      <p:pic>
-        <p:nvPicPr>
-          <p:cNvPr id="3" name="Picture 2" descr="diagram_click.png"/>
-          <p:cNvPicPr>
-            <a:picLocks noChangeAspect="1"/>
-          </p:cNvPicPr>
-          <p:nvPr/>
-        </p:nvPicPr>
-        <p:blipFill>
-          <a:blip r:embed="rId2"/>
-          <a:stretch>
-            <a:fillRect/>
-          </a:stretch>
-        </p:blipFill>
-        <p:spPr>
-          <a:xfrm>
-            <a:off x="594360" y="960120"/>
-            <a:ext cx="10972800" cy="5047488"/>
-          </a:xfrm>
-          <a:prstGeom prst="rect">
-            <a:avLst/>
-          </a:prstGeom>
-        </p:spPr>
-      </p:pic>
-      <p:sp>
-        <p:nvSpPr>
-          <p:cNvPr id="4" name="TextBox 3"/>
-          <p:cNvSpPr txBox="1"/>
-          <p:nvPr/>
-        </p:nvSpPr>
-        <p:spPr>
-          <a:xfrm>
-            <a:off x="548640" y="6144768"/>
-            <a:ext cx="11064240" cy="502920"/>
-          </a:xfrm>
-          <a:prstGeom prst="rect">
-            <a:avLst/>
-          </a:prstGeom>
-          <a:noFill/>
-        </p:spPr>
-        <p:txBody>
-          <a:bodyPr wrap="none">
-            <a:spAutoFit/>
-          </a:bodyPr>
+              <a:t>2 — touch</a:t>
+            </a:r>
+          </a:p>
+        </p:txBody>
+      </p:sp>
+      <p:sp>
+        <p:nvSpPr>
+          <p:cNvPr id="3" name="Content Placeholder 2"/>
+          <p:cNvSpPr>
+            <a:spLocks noGrp="1"/>
+          </p:cNvSpPr>
+          <p:nvPr>
+            <p:ph idx="1"/>
+          </p:nvPr>
+        </p:nvSpPr>
+        <p:spPr/>
+        <p:txBody>
+          <a:bodyPr/>
           <a:lstStyle/>
           <a:p>
             <a:pPr>
-              <a:defRPr sz="1300" i="1">
+              <a:defRPr sz="2100">
                 <a:latin typeface="Calibri"/>
               </a:defRPr>
             </a:pPr>
             <a:r>
-              <a:t>One event name in your code; browser merges mouse or tap into this signal when appropriate.</a:t>
+              <a:t>addEventListener("touchstart" | "touchmove" | "touchend" | "touchcancel", fn).</a:t>
+            </a:r>
+          </a:p>
+          <a:p>
+            <a:pPr>
+              <a:defRPr sz="2100">
+                <a:latin typeface="Calibri"/>
+              </a:defRPr>
+            </a:pPr>
+            <a:r>
+              <a:t>touchstart → many touchmove → touchend / cancel — finger path.</a:t>
+            </a:r>
+          </a:p>
+          <a:p>
+            <a:pPr>
+              <a:defRPr sz="2100">
+                <a:latin typeface="Calibri"/>
+              </a:defRPr>
+            </a:pPr>
+            <a:r>
+              <a:t>e.g. map pan, slider thumb, swipe / pull — read touchmove or pointermove.</a:t>
+            </a:r>
+          </a:p>
+          <a:p>
+            <a:pPr>
+              <a:defRPr sz="2100">
+                <a:latin typeface="Calibri"/>
+              </a:defRPr>
+            </a:pPr>
+            <a:r>
+              <a:t>No touchstart from a real mouse; demo: touch* lines only on glass.</a:t>
             </a:r>
           </a:p>
         </p:txBody>
@@ -3490,7 +3352,7 @@
 </file>
 
 <file path=ppt/slides/slide4.xml><?xml version="1.0" encoding="utf-8"?>
-<p:sld xmlns:a="http://schemas.openxmlformats.org/drawingml/2006/main" xmlns:p="http://schemas.openxmlformats.org/presentationml/2006/main" xmlns:r="http://schemas.openxmlformats.org/officeDocument/2006/relationships">
+<p:sld xmlns:a="http://schemas.openxmlformats.org/drawingml/2006/main" xmlns:r="http://schemas.openxmlformats.org/officeDocument/2006/relationships" xmlns:p="http://schemas.openxmlformats.org/presentationml/2006/main">
   <p:cSld>
     <p:spTree>
       <p:nvGrpSpPr>
@@ -3498,7 +3360,14 @@
         <p:cNvGrpSpPr/>
         <p:nvPr/>
       </p:nvGrpSpPr>
-      <p:grpSpPr/>
+      <p:grpSpPr>
+        <a:xfrm>
+          <a:off x="0" y="0"/>
+          <a:ext cx="0" cy="0"/>
+          <a:chOff x="0" y="0"/>
+          <a:chExt cx="0" cy="0"/>
+        </a:xfrm>
+      </p:grpSpPr>
       <p:sp>
         <p:nvSpPr>
           <p:cNvPr id="2" name="Title 1"/>
@@ -3509,136 +3378,32 @@
             <p:ph type="title"/>
           </p:nvPr>
         </p:nvSpPr>
-        <p:spPr/>
-        <p:txBody>
-          <a:bodyPr/>
-          <a:lstStyle/>
-          <a:p>
-            <a:r>
-              <a:t>Touch</a:t>
-            </a:r>
-          </a:p>
-        </p:txBody>
-      </p:sp>
-      <p:sp>
-        <p:nvSpPr>
-          <p:cNvPr id="3" name="Content Placeholder 2"/>
-          <p:cNvSpPr>
-            <a:spLocks noGrp="1"/>
-          </p:cNvSpPr>
-          <p:nvPr>
-            <p:ph idx="1"/>
-          </p:nvPr>
-        </p:nvSpPr>
-        <p:spPr/>
-        <p:txBody>
-          <a:bodyPr/>
-          <a:lstStyle/>
-          <a:p>
-            <a:pPr>
-              <a:defRPr sz="2200">
-                <a:latin typeface="Calibri"/>
-              </a:defRPr>
-            </a:pPr>
-            <a:r>
-              <a:t>Several DOM events: touchstart → touchmove (many times) → touchend or touchcancel.</a:t>
-            </a:r>
-          </a:p>
-          <a:p>
-            <a:pPr>
-              <a:defRPr sz="2200">
-                <a:latin typeface="Calibri"/>
-              </a:defRPr>
-            </a:pPr>
-            <a:r>
-              <a:t>Describes the whole finger movement until it ends — a timeline, not one beep.</a:t>
-            </a:r>
-          </a:p>
-          <a:p>
-            <a:pPr>
-              <a:defRPr sz="2200">
-                <a:latin typeface="Calibri"/>
-              </a:defRPr>
-            </a:pPr>
-            <a:r>
-              <a:t>Good when you care where the finger is while it moves (drag, draw, swipe).</a:t>
-            </a:r>
-          </a:p>
-        </p:txBody>
-      </p:sp>
-    </p:spTree>
-  </p:cSld>
-  <p:clrMapOvr>
-    <a:masterClrMapping/>
-  </p:clrMapOvr>
-</p:sld>
-</file>
-
-<file path=ppt/slides/slide5.xml><?xml version="1.0" encoding="utf-8"?>
-<p:sld xmlns:a="http://schemas.openxmlformats.org/drawingml/2006/main" xmlns:p="http://schemas.openxmlformats.org/presentationml/2006/main" xmlns:r="http://schemas.openxmlformats.org/officeDocument/2006/relationships">
-  <p:cSld>
-    <p:spTree>
-      <p:nvGrpSpPr>
-        <p:cNvPr id="1" name=""/>
-        <p:cNvGrpSpPr/>
-        <p:nvPr/>
-      </p:nvGrpSpPr>
-      <p:grpSpPr/>
-      <p:sp>
-        <p:nvSpPr>
-          <p:cNvPr id="2" name="Title 1"/>
-          <p:cNvSpPr>
-            <a:spLocks noGrp="1"/>
-          </p:cNvSpPr>
-          <p:nvPr>
-            <p:ph type="title"/>
-          </p:nvPr>
-        </p:nvSpPr>
-        <p:spPr/>
-        <p:txBody>
-          <a:bodyPr/>
-          <a:lstStyle/>
-          <a:p>
-            <a:r>
-              <a:t>Figure — touch event timeline</a:t>
-            </a:r>
-          </a:p>
-        </p:txBody>
-      </p:sp>
-      <p:pic>
-        <p:nvPicPr>
-          <p:cNvPr id="3" name="Picture 2" descr="diagram_touch_timeline.png"/>
-          <p:cNvPicPr>
-            <a:picLocks noChangeAspect="1"/>
-          </p:cNvPicPr>
-          <p:nvPr/>
-        </p:nvPicPr>
-        <p:blipFill>
-          <a:blip r:embed="rId2"/>
-          <a:stretch>
-            <a:fillRect/>
-          </a:stretch>
-        </p:blipFill>
         <p:spPr>
           <a:xfrm>
-            <a:off x="594360" y="960120"/>
-            <a:ext cx="10972800" cy="5157216"/>
+            <a:off x="457200" y="274638"/>
+            <a:ext cx="11155680" cy="1143000"/>
           </a:xfrm>
-          <a:prstGeom prst="rect">
-            <a:avLst/>
-          </a:prstGeom>
         </p:spPr>
-      </p:pic>
-      <p:sp>
-        <p:nvSpPr>
-          <p:cNvPr id="4" name="TextBox 3"/>
+        <p:txBody>
+          <a:bodyPr/>
+          <a:lstStyle/>
+          <a:p>
+            <a:r>
+              <a:t>3 — Windows vs touchscreen (same click())</a:t>
+            </a:r>
+          </a:p>
+        </p:txBody>
+      </p:sp>
+      <p:sp>
+        <p:nvSpPr>
+          <p:cNvPr id="3" name="TextBox 2"/>
           <p:cNvSpPr txBox="1"/>
           <p:nvPr/>
         </p:nvSpPr>
         <p:spPr>
           <a:xfrm>
-            <a:off x="548640" y="6144768"/>
-            <a:ext cx="11064240" cy="502920"/>
+            <a:off x="457200" y="1680147"/>
+            <a:ext cx="11155680" cy="384048"/>
           </a:xfrm>
           <a:prstGeom prst="rect">
             <a:avLst/>
@@ -3646,593 +3411,419 @@
           <a:noFill/>
         </p:spPr>
         <p:txBody>
-          <a:bodyPr wrap="none">
+          <a:bodyPr wrap="square">
             <a:spAutoFit/>
           </a:bodyPr>
           <a:lstStyle/>
           <a:p>
             <a:pPr>
-              <a:defRPr sz="1300" i="1">
+              <a:defRPr sz="1100" i="1">
                 <a:latin typeface="Calibri"/>
               </a:defRPr>
             </a:pPr>
             <a:r>
-              <a:t>Gray box = optional; touchcancel happens when the browser gives up on tracking (e.g. scroll).</a:t>
-            </a:r>
-          </a:p>
-        </p:txBody>
-      </p:sp>
-    </p:spTree>
-  </p:cSld>
-  <p:clrMapOvr>
-    <a:masterClrMapping/>
-  </p:clrMapOvr>
-</p:sld>
-</file>
-
-<file path=ppt/slides/slide6.xml><?xml version="1.0" encoding="utf-8"?>
-<p:sld xmlns:a="http://schemas.openxmlformats.org/drawingml/2006/main" xmlns:p="http://schemas.openxmlformats.org/presentationml/2006/main" xmlns:r="http://schemas.openxmlformats.org/officeDocument/2006/relationships">
-  <p:cSld>
-    <p:spTree>
-      <p:nvGrpSpPr>
-        <p:cNvPr id="1" name=""/>
-        <p:cNvGrpSpPr/>
-        <p:nvPr/>
-      </p:nvGrpSpPr>
-      <p:grpSpPr/>
-      <p:sp>
-        <p:nvSpPr>
-          <p:cNvPr id="2" name="Title 1"/>
-          <p:cNvSpPr>
-            <a:spLocks noGrp="1"/>
-          </p:cNvSpPr>
-          <p:nvPr>
-            <p:ph type="title"/>
-          </p:nvPr>
-        </p:nvSpPr>
-        <p:spPr/>
-        <p:txBody>
-          <a:bodyPr/>
-          <a:lstStyle/>
-          <a:p>
-            <a:r>
-              <a:t>Side by side</a:t>
-            </a:r>
-          </a:p>
-        </p:txBody>
-      </p:sp>
-      <p:sp>
-        <p:nvSpPr>
-          <p:cNvPr id="3" name="Content Placeholder 2"/>
-          <p:cNvSpPr>
-            <a:spLocks noGrp="1"/>
-          </p:cNvSpPr>
-          <p:nvPr>
-            <p:ph idx="1"/>
-          </p:nvPr>
-        </p:nvSpPr>
-        <p:spPr/>
-        <p:txBody>
-          <a:bodyPr/>
-          <a:lstStyle/>
-          <a:p>
-            <a:pPr>
-              <a:defRPr sz="2100">
-                <a:latin typeface="Calibri"/>
-              </a:defRPr>
-            </a:pPr>
-            <a:r>
-              <a:t>Touch = long story of the finger. Click = short “that counted as a button press” at the end (often).</a:t>
-            </a:r>
-          </a:p>
-          <a:p>
-            <a:pPr>
-              <a:defRPr sz="2100">
-                <a:latin typeface="Calibri"/>
-              </a:defRPr>
-            </a:pPr>
-            <a:r>
-              <a:t>One tap on a phone can produce touch events first, then a click — same gesture, different layers.</a:t>
-            </a:r>
-          </a:p>
-          <a:p>
-            <a:pPr>
-              <a:defRPr sz="2100">
-                <a:latin typeface="Calibri"/>
-              </a:defRPr>
-            </a:pPr>
-            <a:r>
-              <a:t>Do not run the same important logic twice on both touchend and click unless you guard it.</a:t>
-            </a:r>
-          </a:p>
-        </p:txBody>
-      </p:sp>
-    </p:spTree>
-  </p:cSld>
-  <p:clrMapOvr>
-    <a:masterClrMapping/>
-  </p:clrMapOvr>
-</p:sld>
-</file>
-
-<file path=ppt/slides/slide7.xml><?xml version="1.0" encoding="utf-8"?>
-<p:sld xmlns:a="http://schemas.openxmlformats.org/drawingml/2006/main" xmlns:p="http://schemas.openxmlformats.org/presentationml/2006/main" xmlns:r="http://schemas.openxmlformats.org/officeDocument/2006/relationships">
-  <p:cSld>
-    <p:spTree>
-      <p:nvGrpSpPr>
-        <p:cNvPr id="1" name=""/>
-        <p:cNvGrpSpPr/>
-        <p:nvPr/>
-      </p:nvGrpSpPr>
-      <p:grpSpPr/>
-      <p:sp>
-        <p:nvSpPr>
-          <p:cNvPr id="2" name="Title 1"/>
-          <p:cNvSpPr>
-            <a:spLocks noGrp="1"/>
-          </p:cNvSpPr>
-          <p:nvPr>
-            <p:ph type="title"/>
-          </p:nvPr>
-        </p:nvSpPr>
-        <p:spPr/>
-        <p:txBody>
-          <a:bodyPr/>
-          <a:lstStyle/>
-          <a:p>
-            <a:r>
-              <a:t>Figure — one tap, two layers</a:t>
-            </a:r>
-          </a:p>
-        </p:txBody>
-      </p:sp>
-      <p:pic>
-        <p:nvPicPr>
-          <p:cNvPr id="3" name="Picture 2" descr="diagram_compare_layers.png"/>
-          <p:cNvPicPr>
-            <a:picLocks noChangeAspect="1"/>
-          </p:cNvPicPr>
-          <p:nvPr/>
-        </p:nvPicPr>
-        <p:blipFill>
-          <a:blip r:embed="rId2"/>
-          <a:stretch>
-            <a:fillRect/>
-          </a:stretch>
-        </p:blipFill>
-        <p:spPr>
-          <a:xfrm>
-            <a:off x="594360" y="960120"/>
-            <a:ext cx="10972800" cy="4498848"/>
-          </a:xfrm>
-          <a:prstGeom prst="rect">
-            <a:avLst/>
-          </a:prstGeom>
-        </p:spPr>
-      </p:pic>
-      <p:sp>
-        <p:nvSpPr>
-          <p:cNvPr id="4" name="TextBox 3"/>
-          <p:cNvSpPr txBox="1"/>
-          <p:nvPr/>
-        </p:nvSpPr>
-        <p:spPr>
-          <a:xfrm>
-            <a:off x="548640" y="6144768"/>
-            <a:ext cx="11064240" cy="502920"/>
-          </a:xfrm>
-          <a:prstGeom prst="rect">
-            <a:avLst/>
-          </a:prstGeom>
-          <a:noFill/>
-        </p:spPr>
-        <p:txBody>
-          <a:bodyPr wrap="none">
-            <a:spAutoFit/>
-          </a:bodyPr>
-          <a:lstStyle/>
-          <a:p>
-            <a:pPr>
-              <a:defRPr sz="1300" i="1">
-                <a:latin typeface="Calibri"/>
-              </a:defRPr>
-            </a:pPr>
-            <a:r>
-              <a:t>Same physical tap: first the touch timeline, then sometimes a click — not two separate user actions.</a:t>
-            </a:r>
-          </a:p>
-        </p:txBody>
-      </p:sp>
-    </p:spTree>
-  </p:cSld>
-  <p:clrMapOvr>
-    <a:masterClrMapping/>
-  </p:clrMapOvr>
-</p:sld>
-</file>
-
-<file path=ppt/slides/slide8.xml><?xml version="1.0" encoding="utf-8"?>
-<p:sld xmlns:a="http://schemas.openxmlformats.org/drawingml/2006/main" xmlns:p="http://schemas.openxmlformats.org/presentationml/2006/main" xmlns:r="http://schemas.openxmlformats.org/officeDocument/2006/relationships">
-  <p:cSld>
-    <p:spTree>
-      <p:nvGrpSpPr>
-        <p:cNvPr id="1" name=""/>
-        <p:cNvGrpSpPr/>
-        <p:nvPr/>
-      </p:nvGrpSpPr>
-      <p:grpSpPr/>
-      <p:sp>
-        <p:nvSpPr>
-          <p:cNvPr id="2" name="Title 1"/>
-          <p:cNvSpPr>
-            <a:spLocks noGrp="1"/>
-          </p:cNvSpPr>
-          <p:nvPr>
-            <p:ph type="title"/>
-          </p:nvPr>
-        </p:nvSpPr>
-        <p:spPr/>
-        <p:txBody>
-          <a:bodyPr/>
-          <a:lstStyle/>
-          <a:p>
-            <a:r>
-              <a:t>DOM event API names (addEventListener)</a:t>
-            </a:r>
-          </a:p>
-        </p:txBody>
-      </p:sp>
-      <p:sp>
-        <p:nvSpPr>
-          <p:cNvPr id="3" name="Content Placeholder 2"/>
-          <p:cNvSpPr>
-            <a:spLocks noGrp="1"/>
-          </p:cNvSpPr>
-          <p:nvPr>
-            <p:ph idx="1"/>
-          </p:nvPr>
-        </p:nvSpPr>
-        <p:spPr/>
-        <p:txBody>
-          <a:bodyPr/>
-          <a:lstStyle/>
-          <a:p>
-            <a:pPr>
-              <a:defRPr sz="1900" b="1">
-                <a:latin typeface="Calibri"/>
-              </a:defRPr>
-            </a:pPr>
-            <a:r>
-              <a:t>Touch — finger timeline</a:t>
-            </a:r>
-          </a:p>
-          <a:p>
-            <a:pPr lvl="1">
-              <a:defRPr sz="1700">
-                <a:latin typeface="Consolas"/>
-              </a:defRPr>
-            </a:pPr>
-            <a:r>
-              <a:t>touchstart</a:t>
-            </a:r>
-          </a:p>
-          <a:p>
-            <a:pPr lvl="1">
-              <a:defRPr sz="1700">
-                <a:latin typeface="Consolas"/>
-              </a:defRPr>
-            </a:pPr>
-            <a:r>
-              <a:t>touchmove</a:t>
-            </a:r>
-          </a:p>
-          <a:p>
-            <a:pPr lvl="1">
-              <a:defRPr sz="1700">
-                <a:latin typeface="Consolas"/>
-              </a:defRPr>
-            </a:pPr>
-            <a:r>
-              <a:t>touchend</a:t>
-            </a:r>
-          </a:p>
-          <a:p>
-            <a:pPr lvl="1">
-              <a:defRPr sz="1700">
-                <a:latin typeface="Consolas"/>
-              </a:defRPr>
-            </a:pPr>
-            <a:r>
-              <a:t>touchcancel</a:t>
-            </a:r>
-          </a:p>
-          <a:p>
-            <a:pPr>
-              <a:defRPr sz="1900" b="1">
-                <a:latin typeface="Calibri"/>
-              </a:defRPr>
-            </a:pPr>
-            <a:r>
-              <a:t>Mouse — press / move / release (desktop; also compatibility on some taps)</a:t>
-            </a:r>
-          </a:p>
-          <a:p>
-            <a:pPr lvl="1">
-              <a:defRPr sz="1700">
-                <a:latin typeface="Consolas"/>
-              </a:defRPr>
-            </a:pPr>
-            <a:r>
-              <a:t>mousedown</a:t>
-            </a:r>
-          </a:p>
-          <a:p>
-            <a:pPr lvl="1">
-              <a:defRPr sz="1700">
-                <a:latin typeface="Consolas"/>
-              </a:defRPr>
-            </a:pPr>
-            <a:r>
-              <a:t>mouseup</a:t>
-            </a:r>
-          </a:p>
-          <a:p>
-            <a:pPr lvl="1">
-              <a:defRPr sz="1700">
-                <a:latin typeface="Consolas"/>
-              </a:defRPr>
-            </a:pPr>
-            <a:r>
-              <a:t>mousemove</a:t>
-            </a:r>
-          </a:p>
-          <a:p>
-            <a:pPr lvl="1">
-              <a:defRPr sz="1700">
-                <a:latin typeface="Consolas"/>
-              </a:defRPr>
-            </a:pPr>
-            <a:r>
-              <a:t>mouseenter</a:t>
-            </a:r>
-          </a:p>
-          <a:p>
-            <a:pPr lvl="1">
-              <a:defRPr sz="1700">
-                <a:latin typeface="Consolas"/>
-              </a:defRPr>
-            </a:pPr>
-            <a:r>
-              <a:t>mouseleave</a:t>
-            </a:r>
-          </a:p>
-          <a:p>
-            <a:pPr lvl="1">
-              <a:defRPr sz="1700">
-                <a:latin typeface="Consolas"/>
-              </a:defRPr>
-            </a:pPr>
-            <a:r>
-              <a:t>mouseover</a:t>
-            </a:r>
-          </a:p>
-          <a:p>
-            <a:pPr lvl="1">
-              <a:defRPr sz="1700">
-                <a:latin typeface="Consolas"/>
-              </a:defRPr>
-            </a:pPr>
-            <a:r>
-              <a:t>mouseout</a:t>
-            </a:r>
-          </a:p>
-          <a:p>
-            <a:pPr>
-              <a:defRPr sz="1900" b="1">
-                <a:latin typeface="Calibri"/>
-              </a:defRPr>
-            </a:pPr>
-            <a:r>
-              <a:t>Click / activation (short signal)</a:t>
-            </a:r>
-          </a:p>
-          <a:p>
-            <a:pPr lvl="1">
-              <a:defRPr sz="1700">
-                <a:latin typeface="Consolas"/>
-              </a:defRPr>
-            </a:pPr>
-            <a:r>
-              <a:t>click</a:t>
-            </a:r>
-          </a:p>
-          <a:p>
-            <a:pPr lvl="1">
-              <a:defRPr sz="1700">
-                <a:latin typeface="Consolas"/>
-              </a:defRPr>
-            </a:pPr>
-            <a:r>
-              <a:t>dblclick</a:t>
-            </a:r>
-          </a:p>
-          <a:p>
-            <a:pPr lvl="1">
-              <a:defRPr sz="1700">
-                <a:latin typeface="Consolas"/>
-              </a:defRPr>
-            </a:pPr>
-            <a:r>
-              <a:t>auxclick</a:t>
-            </a:r>
-          </a:p>
-          <a:p>
-            <a:pPr lvl="1">
-              <a:defRPr sz="1700">
-                <a:latin typeface="Consolas"/>
-              </a:defRPr>
-            </a:pPr>
-            <a:r>
-              <a:t>contextmenu</a:t>
-            </a:r>
-          </a:p>
-          <a:p>
-            <a:pPr>
-              <a:defRPr sz="1900" b="1">
-                <a:latin typeface="Calibri"/>
-              </a:defRPr>
-            </a:pPr>
-            <a:r>
-              <a:t>Pointer Events — one model for mouse + touch + pen (common for drags)</a:t>
-            </a:r>
-          </a:p>
-          <a:p>
-            <a:pPr lvl="1">
-              <a:defRPr sz="1700">
-                <a:latin typeface="Consolas"/>
-              </a:defRPr>
-            </a:pPr>
-            <a:r>
-              <a:t>pointerdown</a:t>
-            </a:r>
-          </a:p>
-          <a:p>
-            <a:pPr lvl="1">
-              <a:defRPr sz="1700">
-                <a:latin typeface="Consolas"/>
-              </a:defRPr>
-            </a:pPr>
-            <a:r>
-              <a:t>pointermove</a:t>
-            </a:r>
-          </a:p>
-          <a:p>
-            <a:pPr lvl="1">
-              <a:defRPr sz="1700">
-                <a:latin typeface="Consolas"/>
-              </a:defRPr>
-            </a:pPr>
-            <a:r>
-              <a:t>pointerup</a:t>
-            </a:r>
-          </a:p>
-          <a:p>
-            <a:pPr lvl="1">
-              <a:defRPr sz="1700">
-                <a:latin typeface="Consolas"/>
-              </a:defRPr>
-            </a:pPr>
-            <a:r>
-              <a:t>pointercancel</a:t>
-            </a:r>
-          </a:p>
-          <a:p>
-            <a:pPr lvl="1">
-              <a:defRPr sz="1700">
-                <a:latin typeface="Consolas"/>
-              </a:defRPr>
-            </a:pPr>
-            <a:r>
-              <a:t>gotpointercapture</a:t>
-            </a:r>
-          </a:p>
-          <a:p>
-            <a:pPr lvl="1">
-              <a:defRPr sz="1700">
-                <a:latin typeface="Consolas"/>
-              </a:defRPr>
-            </a:pPr>
-            <a:r>
-              <a:t>lostpointercapture</a:t>
-            </a:r>
-          </a:p>
-          <a:p>
-            <a:pPr>
-              <a:defRPr sz="1500" i="1">
-                <a:latin typeface="Calibri"/>
-              </a:defRPr>
-            </a:pPr>
-            <a:r>
-              <a:t>One physical tap can emit events from more than one family — the live demo log shows that.</a:t>
-            </a:r>
-          </a:p>
-        </p:txBody>
-      </p:sp>
-    </p:spTree>
-  </p:cSld>
-  <p:clrMapOvr>
-    <a:masterClrMapping/>
-  </p:clrMapOvr>
-</p:sld>
-</file>
-
-<file path=ppt/slides/slide9.xml><?xml version="1.0" encoding="utf-8"?>
-<p:sld xmlns:a="http://schemas.openxmlformats.org/drawingml/2006/main" xmlns:p="http://schemas.openxmlformats.org/presentationml/2006/main" xmlns:r="http://schemas.openxmlformats.org/officeDocument/2006/relationships">
-  <p:cSld>
-    <p:spTree>
-      <p:nvGrpSpPr>
-        <p:cNvPr id="1" name=""/>
-        <p:cNvGrpSpPr/>
-        <p:nvPr/>
-      </p:nvGrpSpPr>
-      <p:grpSpPr/>
-      <p:sp>
-        <p:nvSpPr>
-          <p:cNvPr id="2" name="Title 1"/>
-          <p:cNvSpPr>
-            <a:spLocks noGrp="1"/>
-          </p:cNvSpPr>
-          <p:nvPr>
-            <p:ph type="title"/>
-          </p:nvPr>
-        </p:nvSpPr>
-        <p:spPr/>
-        <p:txBody>
-          <a:bodyPr/>
-          <a:lstStyle/>
-          <a:p>
-            <a:r>
-              <a:t>Real apps — use click</a:t>
-            </a:r>
-          </a:p>
-        </p:txBody>
-      </p:sp>
-      <p:sp>
-        <p:nvSpPr>
-          <p:cNvPr id="3" name="Content Placeholder 2"/>
-          <p:cNvSpPr>
-            <a:spLocks noGrp="1"/>
-          </p:cNvSpPr>
-          <p:nvPr>
-            <p:ph idx="1"/>
-          </p:nvPr>
-        </p:nvSpPr>
-        <p:spPr/>
-        <p:txBody>
-          <a:bodyPr/>
-          <a:lstStyle/>
-          <a:p>
-            <a:pPr>
-              <a:defRPr sz="2400">
-                <a:latin typeface="Calibri"/>
-              </a:defRPr>
-            </a:pPr>
-            <a:r>
-              <a:t>Submit, OK, open dialog, follow link, toggle menu on a &lt;button&gt;.</a:t>
-            </a:r>
-          </a:p>
-          <a:p>
-            <a:pPr>
-              <a:defRPr sz="2400">
-                <a:latin typeface="Calibri"/>
-              </a:defRPr>
-            </a:pPr>
-            <a:r>
-              <a:t>Anything that should also work with keyboard (Space/Enter) on native buttons.</a:t>
-            </a:r>
-          </a:p>
-        </p:txBody>
-      </p:sp>
+              <a:t>click ≠ mousedown. Finger → click is common, not guaranteed. e.g. [1 tap] on phone: one press → touch* + pointer* + mouse* + click in the log.</a:t>
+            </a:r>
+          </a:p>
+        </p:txBody>
+      </p:sp>
+      <p:graphicFrame>
+        <p:nvGraphicFramePr>
+          <p:cNvPr id="4" name="Table 3"/>
+          <p:cNvGraphicFramePr>
+            <a:graphicFrameLocks noGrp="1"/>
+          </p:cNvGraphicFramePr>
+          <p:nvPr>
+            <p:extLst>
+              <p:ext uri="{D42A27DB-BD31-4B8C-83A1-F6EECF244321}">
+                <p14:modId xmlns:p14="http://schemas.microsoft.com/office/powerpoint/2010/main" val="470909955"/>
+              </p:ext>
+            </p:extLst>
+          </p:nvPr>
+        </p:nvGraphicFramePr>
+        <p:xfrm>
+          <a:off x="502920" y="2326705"/>
+          <a:ext cx="10881360" cy="4069080"/>
+        </p:xfrm>
+        <a:graphic>
+          <a:graphicData uri="http://schemas.openxmlformats.org/drawingml/2006/table">
+            <a:tbl>
+              <a:tblPr firstRow="1" bandRow="1">
+                <a:tableStyleId>{5C22544A-7EE6-4342-B048-85BDC9FD1C3A}</a:tableStyleId>
+              </a:tblPr>
+              <a:tblGrid>
+                <a:gridCol w="1371600">
+                  <a:extLst>
+                    <a:ext uri="{9D8B030D-6E8A-4147-A177-3AD203B41FA5}">
+                      <a16:colId xmlns:a16="http://schemas.microsoft.com/office/drawing/2014/main" val="20000"/>
+                    </a:ext>
+                  </a:extLst>
+                </a:gridCol>
+                <a:gridCol w="4754880">
+                  <a:extLst>
+                    <a:ext uri="{9D8B030D-6E8A-4147-A177-3AD203B41FA5}">
+                      <a16:colId xmlns:a16="http://schemas.microsoft.com/office/drawing/2014/main" val="20001"/>
+                    </a:ext>
+                  </a:extLst>
+                </a:gridCol>
+                <a:gridCol w="4754880">
+                  <a:extLst>
+                    <a:ext uri="{9D8B030D-6E8A-4147-A177-3AD203B41FA5}">
+                      <a16:colId xmlns:a16="http://schemas.microsoft.com/office/drawing/2014/main" val="20002"/>
+                    </a:ext>
+                  </a:extLst>
+                </a:gridCol>
+              </a:tblGrid>
+              <a:tr h="678180">
+                <a:tc>
+                  <a:txBody>
+                    <a:bodyPr/>
+                    <a:lstStyle/>
+                    <a:p>
+                      <a:pPr>
+                        <a:defRPr sz="1300" b="1">
+                          <a:latin typeface="Calibri"/>
+                        </a:defRPr>
+                      </a:pPr>
+                      <a:endParaRPr/>
+                    </a:p>
+                  </a:txBody>
+                  <a:tcPr/>
+                </a:tc>
+                <a:tc>
+                  <a:txBody>
+                    <a:bodyPr/>
+                    <a:lstStyle/>
+                    <a:p>
+                      <a:pPr>
+                        <a:defRPr sz="1300" b="1">
+                          <a:latin typeface="Calibri"/>
+                        </a:defRPr>
+                      </a:pPr>
+                      <a:r>
+                        <a:t>Windows</a:t>
+                      </a:r>
+                    </a:p>
+                  </a:txBody>
+                  <a:tcPr/>
+                </a:tc>
+                <a:tc>
+                  <a:txBody>
+                    <a:bodyPr/>
+                    <a:lstStyle/>
+                    <a:p>
+                      <a:pPr>
+                        <a:defRPr sz="1300" b="1">
+                          <a:latin typeface="Calibri"/>
+                        </a:defRPr>
+                      </a:pPr>
+                      <a:r>
+                        <a:t>Touch</a:t>
+                      </a:r>
+                    </a:p>
+                  </a:txBody>
+                  <a:tcPr/>
+                </a:tc>
+                <a:extLst>
+                  <a:ext uri="{0D108BD9-81ED-4DB2-BD59-A6C34878D82A}">
+                    <a16:rowId xmlns:a16="http://schemas.microsoft.com/office/drawing/2014/main" val="10000"/>
+                  </a:ext>
+                </a:extLst>
+              </a:tr>
+              <a:tr h="678180">
+                <a:tc>
+                  <a:txBody>
+                    <a:bodyPr/>
+                    <a:lstStyle/>
+                    <a:p>
+                      <a:pPr>
+                        <a:defRPr sz="1200" b="0">
+                          <a:latin typeface="Calibri"/>
+                        </a:defRPr>
+                      </a:pPr>
+                      <a:r>
+                        <a:t>Stream</a:t>
+                      </a:r>
+                    </a:p>
+                  </a:txBody>
+                  <a:tcPr/>
+                </a:tc>
+                <a:tc>
+                  <a:txBody>
+                    <a:bodyPr/>
+                    <a:lstStyle/>
+                    <a:p>
+                      <a:pPr>
+                        <a:defRPr sz="1200" b="0">
+                          <a:latin typeface="Calibri"/>
+                        </a:defRPr>
+                      </a:pPr>
+                      <a:r>
+                        <a:t>pointer* + mousedown…</a:t>
+                      </a:r>
+                    </a:p>
+                  </a:txBody>
+                  <a:tcPr/>
+                </a:tc>
+                <a:tc>
+                  <a:txBody>
+                    <a:bodyPr/>
+                    <a:lstStyle/>
+                    <a:p>
+                      <a:pPr>
+                        <a:defRPr sz="1200" b="0">
+                          <a:latin typeface="Calibri"/>
+                        </a:defRPr>
+                      </a:pPr>
+                      <a:r>
+                        <a:t>touchstart… + pointer*</a:t>
+                      </a:r>
+                    </a:p>
+                  </a:txBody>
+                  <a:tcPr/>
+                </a:tc>
+                <a:extLst>
+                  <a:ext uri="{0D108BD9-81ED-4DB2-BD59-A6C34878D82A}">
+                    <a16:rowId xmlns:a16="http://schemas.microsoft.com/office/drawing/2014/main" val="10001"/>
+                  </a:ext>
+                </a:extLst>
+              </a:tr>
+              <a:tr h="678180">
+                <a:tc>
+                  <a:txBody>
+                    <a:bodyPr/>
+                    <a:lstStyle/>
+                    <a:p>
+                      <a:pPr>
+                        <a:defRPr sz="1200" b="0">
+                          <a:latin typeface="Calibri"/>
+                        </a:defRPr>
+                      </a:pPr>
+                      <a:r>
+                        <a:t>touch*</a:t>
+                      </a:r>
+                    </a:p>
+                  </a:txBody>
+                  <a:tcPr/>
+                </a:tc>
+                <a:tc>
+                  <a:txBody>
+                    <a:bodyPr/>
+                    <a:lstStyle/>
+                    <a:p>
+                      <a:pPr>
+                        <a:defRPr sz="1200" b="0">
+                          <a:latin typeface="Calibri"/>
+                        </a:defRPr>
+                      </a:pPr>
+                      <a:r>
+                        <a:t>No</a:t>
+                      </a:r>
+                    </a:p>
+                  </a:txBody>
+                  <a:tcPr/>
+                </a:tc>
+                <a:tc>
+                  <a:txBody>
+                    <a:bodyPr/>
+                    <a:lstStyle/>
+                    <a:p>
+                      <a:pPr>
+                        <a:defRPr sz="1200" b="0">
+                          <a:latin typeface="Calibri"/>
+                        </a:defRPr>
+                      </a:pPr>
+                      <a:r>
+                        <a:t>Yes</a:t>
+                      </a:r>
+                    </a:p>
+                  </a:txBody>
+                  <a:tcPr/>
+                </a:tc>
+                <a:extLst>
+                  <a:ext uri="{0D108BD9-81ED-4DB2-BD59-A6C34878D82A}">
+                    <a16:rowId xmlns:a16="http://schemas.microsoft.com/office/drawing/2014/main" val="10002"/>
+                  </a:ext>
+                </a:extLst>
+              </a:tr>
+              <a:tr h="678180">
+                <a:tc>
+                  <a:txBody>
+                    <a:bodyPr/>
+                    <a:lstStyle/>
+                    <a:p>
+                      <a:pPr>
+                        <a:defRPr sz="1200" b="0">
+                          <a:latin typeface="Calibri"/>
+                        </a:defRPr>
+                      </a:pPr>
+                      <a:r>
+                        <a:t>mouse*</a:t>
+                      </a:r>
+                    </a:p>
+                  </a:txBody>
+                  <a:tcPr/>
+                </a:tc>
+                <a:tc>
+                  <a:txBody>
+                    <a:bodyPr/>
+                    <a:lstStyle/>
+                    <a:p>
+                      <a:pPr>
+                        <a:defRPr sz="1200" b="0">
+                          <a:latin typeface="Calibri"/>
+                        </a:defRPr>
+                      </a:pPr>
+                      <a:r>
+                        <a:t>Yes (real)</a:t>
+                      </a:r>
+                    </a:p>
+                  </a:txBody>
+                  <a:tcPr/>
+                </a:tc>
+                <a:tc>
+                  <a:txBody>
+                    <a:bodyPr/>
+                    <a:lstStyle/>
+                    <a:p>
+                      <a:pPr>
+                        <a:defRPr sz="1200" b="0">
+                          <a:latin typeface="Calibri"/>
+                        </a:defRPr>
+                      </a:pPr>
+                      <a:r>
+                        <a:t>Often synth</a:t>
+                      </a:r>
+                    </a:p>
+                  </a:txBody>
+                  <a:tcPr/>
+                </a:tc>
+                <a:extLst>
+                  <a:ext uri="{0D108BD9-81ED-4DB2-BD59-A6C34878D82A}">
+                    <a16:rowId xmlns:a16="http://schemas.microsoft.com/office/drawing/2014/main" val="10003"/>
+                  </a:ext>
+                </a:extLst>
+              </a:tr>
+              <a:tr h="678180">
+                <a:tc>
+                  <a:txBody>
+                    <a:bodyPr/>
+                    <a:lstStyle/>
+                    <a:p>
+                      <a:pPr>
+                        <a:defRPr sz="1200" b="0">
+                          <a:latin typeface="Calibri"/>
+                        </a:defRPr>
+                      </a:pPr>
+                      <a:r>
+                        <a:t>click</a:t>
+                      </a:r>
+                    </a:p>
+                  </a:txBody>
+                  <a:tcPr/>
+                </a:tc>
+                <a:tc>
+                  <a:txBody>
+                    <a:bodyPr/>
+                    <a:lstStyle/>
+                    <a:p>
+                      <a:pPr>
+                        <a:defRPr sz="1200" b="0">
+                          <a:latin typeface="Calibri"/>
+                        </a:defRPr>
+                      </a:pPr>
+                      <a:r>
+                        <a:t>Usually</a:t>
+                      </a:r>
+                    </a:p>
+                  </a:txBody>
+                  <a:tcPr/>
+                </a:tc>
+                <a:tc>
+                  <a:txBody>
+                    <a:bodyPr/>
+                    <a:lstStyle/>
+                    <a:p>
+                      <a:pPr>
+                        <a:defRPr sz="1200" b="0">
+                          <a:latin typeface="Calibri"/>
+                        </a:defRPr>
+                      </a:pPr>
+                      <a:r>
+                        <a:t>Often</a:t>
+                      </a:r>
+                    </a:p>
+                  </a:txBody>
+                  <a:tcPr/>
+                </a:tc>
+                <a:extLst>
+                  <a:ext uri="{0D108BD9-81ED-4DB2-BD59-A6C34878D82A}">
+                    <a16:rowId xmlns:a16="http://schemas.microsoft.com/office/drawing/2014/main" val="10004"/>
+                  </a:ext>
+                </a:extLst>
+              </a:tr>
+              <a:tr h="678180">
+                <a:tc>
+                  <a:txBody>
+                    <a:bodyPr/>
+                    <a:lstStyle/>
+                    <a:p>
+                      <a:pPr>
+                        <a:defRPr sz="1200" b="0">
+                          <a:latin typeface="Calibri"/>
+                        </a:defRPr>
+                      </a:pPr>
+                      <a:r>
+                        <a:t>Same</a:t>
+                      </a:r>
+                    </a:p>
+                  </a:txBody>
+                  <a:tcPr/>
+                </a:tc>
+                <a:tc>
+                  <a:txBody>
+                    <a:bodyPr/>
+                    <a:lstStyle/>
+                    <a:p>
+                      <a:pPr>
+                        <a:defRPr sz="1200" b="0">
+                          <a:latin typeface="Calibri"/>
+                        </a:defRPr>
+                      </a:pPr>
+                      <a:r>
+                        <a:t>addEventListener("click")</a:t>
+                      </a:r>
+                    </a:p>
+                  </a:txBody>
+                  <a:tcPr/>
+                </a:tc>
+                <a:tc>
+                  <a:txBody>
+                    <a:bodyPr/>
+                    <a:lstStyle/>
+                    <a:p>
+                      <a:pPr>
+                        <a:defRPr sz="1200" b="0">
+                          <a:latin typeface="Calibri"/>
+                        </a:defRPr>
+                      </a:pPr>
+                      <a:r>
+                        <a:t>addEventListener("click")</a:t>
+                      </a:r>
+                    </a:p>
+                  </a:txBody>
+                  <a:tcPr/>
+                </a:tc>
+                <a:extLst>
+                  <a:ext uri="{0D108BD9-81ED-4DB2-BD59-A6C34878D82A}">
+                    <a16:rowId xmlns:a16="http://schemas.microsoft.com/office/drawing/2014/main" val="10005"/>
+                  </a:ext>
+                </a:extLst>
+              </a:tr>
+            </a:tbl>
+          </a:graphicData>
+        </a:graphic>
+      </p:graphicFrame>
     </p:spTree>
   </p:cSld>
   <p:clrMapOvr>

</xml_diff>